<commit_message>
Make auto-translator lossless for images + better quote detection
- Deck.media(): split slide (text left, image right) so pictures from a
  source deck are carried, not dropped.
- auto_translate.py: extract embedded images (MSO_SHAPE_TYPE.PICTURE) and
  route image-bearing slides to media(); detect quotes by scanning body
  lines (not just the title) -> proper coral pull-quote with attribution.
- make_legacy.py: the sample About slide now embeds an image to exercise it.
Verified: image carried, testimonial -> pull-quote, 99% tokens (only the
literal 'Metric' table header drops).

https://claude.ai/code/session_018CuPeTbPKyC5roqRrfQGYh
</commit_message>
<xml_diff>
--- a/design-system/samples/legacy-overview.pptx
+++ b/design-system/samples/legacy-overview.pptx
@@ -4272,7 +4272,7 @@
         <p:spPr>
           <a:xfrm>
             <a:off x="640080" y="1371600"/>
-            <a:ext cx="10972800" cy="1463040"/>
+            <a:ext cx="6675120" cy="1645920"/>
           </a:xfrm>
           <a:prstGeom prst="rect">
             <a:avLst/>
@@ -4291,7 +4291,7 @@
               </a:spcAft>
             </a:pPr>
             <a:r>
-              <a:rPr sz="1600" b="0" i="0">
+              <a:rPr sz="1500" b="0" i="0">
                 <a:solidFill>
                   <a:srgbClr val="262626"/>
                 </a:solidFill>
@@ -4310,8 +4310,8 @@
         </p:nvSpPr>
         <p:spPr>
           <a:xfrm>
-            <a:off x="640080" y="2926080"/>
-            <a:ext cx="10972800" cy="3383279"/>
+            <a:off x="640080" y="3108960"/>
+            <a:ext cx="6400800" cy="3200399"/>
           </a:xfrm>
           <a:prstGeom prst="rect">
             <a:avLst/>
@@ -4330,7 +4330,7 @@
               </a:spcAft>
             </a:pPr>
             <a:r>
-              <a:rPr sz="1600" b="0" i="0">
+              <a:rPr sz="1500" b="0" i="0">
                 <a:solidFill>
                   <a:srgbClr val="262626"/>
                 </a:solidFill>
@@ -4346,7 +4346,7 @@
               </a:spcAft>
             </a:pPr>
             <a:r>
-              <a:rPr sz="1600" b="0" i="0">
+              <a:rPr sz="1500" b="0" i="0">
                 <a:solidFill>
                   <a:srgbClr val="262626"/>
                 </a:solidFill>
@@ -4362,7 +4362,7 @@
               </a:spcAft>
             </a:pPr>
             <a:r>
-              <a:rPr sz="1600" b="0" i="0">
+              <a:rPr sz="1500" b="0" i="0">
                 <a:solidFill>
                   <a:srgbClr val="262626"/>
                 </a:solidFill>
@@ -4378,7 +4378,7 @@
               </a:spcAft>
             </a:pPr>
             <a:r>
-              <a:rPr sz="1600" b="0" i="0">
+              <a:rPr sz="1500" b="0" i="0">
                 <a:solidFill>
                   <a:srgbClr val="262626"/>
                 </a:solidFill>
@@ -4389,9 +4389,33 @@
           </a:p>
         </p:txBody>
       </p:sp>
-      <p:sp>
-        <p:nvSpPr>
-          <p:cNvPr id="5" name="TextBox 4"/>
+      <p:pic>
+        <p:nvPicPr>
+          <p:cNvPr id="5" name="Picture 4" descr="_legacy_photo.png"/>
+          <p:cNvPicPr>
+            <a:picLocks noChangeAspect="1"/>
+          </p:cNvPicPr>
+          <p:nvPr/>
+        </p:nvPicPr>
+        <p:blipFill>
+          <a:blip r:embed="rId2"/>
+          <a:stretch>
+            <a:fillRect/>
+          </a:stretch>
+        </p:blipFill>
+        <p:spPr>
+          <a:xfrm>
+            <a:off x="7498079" y="1554480"/>
+            <a:ext cx="4114800" cy="2811780"/>
+          </a:xfrm>
+          <a:prstGeom prst="rect">
+            <a:avLst/>
+          </a:prstGeom>
+        </p:spPr>
+      </p:pic>
+      <p:sp>
+        <p:nvSpPr>
+          <p:cNvPr id="6" name="TextBox 5"/>
           <p:cNvSpPr txBox="1"/>
           <p:nvPr/>
         </p:nvSpPr>
@@ -4430,7 +4454,7 @@
       </p:sp>
       <p:sp>
         <p:nvSpPr>
-          <p:cNvPr id="6" name="TextBox 5"/>
+          <p:cNvPr id="7" name="TextBox 6"/>
           <p:cNvSpPr txBox="1"/>
           <p:nvPr/>
         </p:nvSpPr>

</xml_diff>